<commit_message>
Add source-checked literature review and correct citations
Every source cited so far was read in the original and checked claim by
claim. Adds LITERATURE_REVIEW.md with the verdicts, a fuller review, and
what could not be verified. Completes references in the research
explained and both decks (journal versions of Gee et al., Kuenn et al.
and Sunde et al.; pages for Backus et al. and Guid and Bratko), credits
the moves 15-30 window to Guid and Bratko, notes that Lichess ratings
are Glicko-2, and fixes the README link to a review file that did not
exist.

Co-Authored-By: Claude Opus 5.5 <noreply@anthropic.com>
Claude-Session: https://claude.ai/code/session_01M9V7nrLidvW1xnBrcuESwN
</commit_message>
<xml_diff>
--- a/slides/proposal-presentation.pptx
+++ b/slides/proposal-presentation.pptx
@@ -118,7 +118,7 @@
   <p:extLst>
     <p:ext uri="{521415D9-36F7-43E2-AB2F-B90AF26B5E84}">
       <p14:sectionLst xmlns:p14="http://schemas.microsoft.com/office/powerpoint/2010/main">
-        <p14:section name="Introduction" id="{b706ca51-6e5d-c59e-a628-23e165e7b523}">
+        <p14:section name="Introduction" id="{d3514887-1105-4c14-f003-faba63215831}">
           <p14:sldIdLst>
             <p14:sldId id="256"/>
             <p14:sldId id="257"/>
@@ -127,29 +127,29 @@
             <p14:sldId id="260"/>
           </p14:sldIdLst>
         </p14:section>
-        <p14:section name="Research questions" id="{e3ea5c85-fa0e-2df1-03ab-56b4e5da8487}">
+        <p14:section name="Research questions" id="{f74b0310-9fa5-36a5-e1d7-375f363f8a32}">
           <p14:sldIdLst>
             <p14:sldId id="261"/>
           </p14:sldIdLst>
         </p14:section>
-        <p14:section name="Methods" id="{add7ec0e-7353-4a36-2db7-0da9b4531b8d}">
+        <p14:section name="Methods" id="{2f4a84d8-1b54-f17a-aefc-37bdc7172b06}">
           <p14:sldIdLst>
             <p14:sldId id="262"/>
             <p14:sldId id="263"/>
             <p14:sldId id="264"/>
           </p14:sldIdLst>
         </p14:section>
-        <p14:section name="Expected results" id="{375f3a76-8a25-4df9-ad29-8cb0e347e57b}">
+        <p14:section name="Expected results" id="{924af267-9f26-bc19-cd10-ea1203a54561}">
           <p14:sldIdLst>
             <p14:sldId id="265"/>
           </p14:sldIdLst>
         </p14:section>
-        <p14:section name="Conclusions" id="{636d5fc3-8795-c554-9047-e188b6e66a08}">
+        <p14:section name="Conclusions" id="{6b5b7992-69fe-9aff-7573-674e3a955a81}">
           <p14:sldIdLst>
             <p14:sldId id="266"/>
           </p14:sldIdLst>
         </p14:section>
-        <p14:section name="Backup" id="{1a18387f-0dbe-a6c2-28be-0bb0f1c21ceb}">
+        <p14:section name="Backup" id="{95ae57a8-d189-541c-36fd-3019c8f197c3}">
           <p14:sldIdLst>
             <p14:sldId id="267"/>
           </p14:sldIdLst>
@@ -3688,7 +3688,7 @@
                 <a:ea typeface="Arial" pitchFamily="34" charset="-122"/>
                 <a:cs typeface="Arial" pitchFamily="34" charset="-120"/>
               </a:rPr>
-              <a:t>Backus, Cubel, Guid, Sanchez-Pages &amp; Lopez Manas (2023). Quantitative Economics, 14(1).</a:t>
+              <a:t>Backus, Cubel, Guid, Sanchez-Pages &amp; Lopez Manas (2023). Quantitative Economics, 14(1), 349-380.</a:t>
             </a:r>
             <a:endParaRPr lang="en-US" sz="1400" dirty="0"/>
           </a:p>
@@ -3728,7 +3728,7 @@
                 <a:ea typeface="Arial" pitchFamily="34" charset="-122"/>
                 <a:cs typeface="Arial" pitchFamily="34" charset="-120"/>
               </a:rPr>
-              <a:t>Gee, Seese, Curley &amp; Ward (2025). arXiv:2503.21713.</a:t>
+              <a:t>Gee, Seese, Curley &amp; Ward (2025). Journal of Quantitative Analysis in Sports, 22(2), 117-132. Preprint arXiv:2503.21713.</a:t>
             </a:r>
             <a:endParaRPr lang="en-US" sz="1400" dirty="0"/>
           </a:p>
@@ -3748,7 +3748,7 @@
                 <a:ea typeface="Arial" pitchFamily="34" charset="-122"/>
                 <a:cs typeface="Arial" pitchFamily="34" charset="-120"/>
               </a:rPr>
-              <a:t>Guid &amp; Bratko (2006). ICGA Journal.</a:t>
+              <a:t>Guid &amp; Bratko (2006). Computer analysis of world chess champions. ICGA Journal, 29(2), 65-73.</a:t>
             </a:r>
             <a:endParaRPr lang="en-US" sz="1400" dirty="0"/>
           </a:p>

</xml_diff>